<commit_message>
Adição exemplo shape e geo_parquet
</commit_message>
<xml_diff>
--- a/Aula05/Apresentação/STEPWISE_TiposArquivos.pptx
+++ b/Aula05/Apresentação/STEPWISE_TiposArquivos.pptx
@@ -6,7 +6,7 @@
     <p:sldMasterId id="2147483660" r:id="rId5"/>
   </p:sldMasterIdLst>
   <p:notesMasterIdLst>
-    <p:notesMasterId r:id="rId19"/>
+    <p:notesMasterId r:id="rId20"/>
   </p:notesMasterIdLst>
   <p:sldIdLst>
     <p:sldId id="268" r:id="rId6"/>
@@ -21,26 +21,27 @@
     <p:sldId id="349" r:id="rId15"/>
     <p:sldId id="350" r:id="rId16"/>
     <p:sldId id="351" r:id="rId17"/>
-    <p:sldId id="272" r:id="rId18"/>
+    <p:sldId id="352" r:id="rId18"/>
+    <p:sldId id="272" r:id="rId19"/>
   </p:sldIdLst>
   <p:sldSz cx="12192000" cy="6858000"/>
   <p:notesSz cx="6858000" cy="9144000"/>
   <p:embeddedFontLst>
     <p:embeddedFont>
       <p:font typeface="DiN" panose="020B0604020202020204"/>
-      <p:regular r:id="rId20"/>
+      <p:regular r:id="rId21"/>
     </p:embeddedFont>
     <p:embeddedFont>
       <p:font typeface="Gobold" panose="020B0604020202020204" charset="0"/>
-      <p:regular r:id="rId21"/>
-      <p:italic r:id="rId22"/>
+      <p:regular r:id="rId22"/>
+      <p:italic r:id="rId23"/>
     </p:embeddedFont>
     <p:embeddedFont>
       <p:font typeface="Raleway" pitchFamily="2" charset="0"/>
-      <p:regular r:id="rId23"/>
-      <p:bold r:id="rId24"/>
-      <p:italic r:id="rId25"/>
-      <p:boldItalic r:id="rId26"/>
+      <p:regular r:id="rId24"/>
+      <p:bold r:id="rId25"/>
+      <p:italic r:id="rId26"/>
+      <p:boldItalic r:id="rId27"/>
     </p:embeddedFont>
   </p:embeddedFontLst>
   <p:defaultTextStyle>
@@ -9292,6 +9293,322 @@
 </file>
 
 <file path=ppt/slides/slide13.xml><?xml version="1.0" encoding="utf-8"?>
+<p:sld xmlns:a="http://schemas.openxmlformats.org/drawingml/2006/main" xmlns:r="http://schemas.openxmlformats.org/officeDocument/2006/relationships" xmlns:p="http://schemas.openxmlformats.org/presentationml/2006/main">
+  <p:cSld>
+    <p:spTree>
+      <p:nvGrpSpPr>
+        <p:cNvPr id="1" name=""/>
+        <p:cNvGrpSpPr/>
+        <p:nvPr/>
+      </p:nvGrpSpPr>
+      <p:grpSpPr>
+        <a:xfrm>
+          <a:off x="0" y="0"/>
+          <a:ext cx="0" cy="0"/>
+          <a:chOff x="0" y="0"/>
+          <a:chExt cx="0" cy="0"/>
+        </a:xfrm>
+      </p:grpSpPr>
+      <p:sp>
+        <p:nvSpPr>
+          <p:cNvPr id="2" name="Espaço Reservado para Número de Slide 1">
+            <a:extLst>
+              <a:ext uri="{FF2B5EF4-FFF2-40B4-BE49-F238E27FC236}">
+                <a16:creationId xmlns:a16="http://schemas.microsoft.com/office/drawing/2014/main" id="{30BD66D1-29D7-51E2-2BAC-9D326CD67B13}"/>
+              </a:ext>
+            </a:extLst>
+          </p:cNvPr>
+          <p:cNvSpPr>
+            <a:spLocks noGrp="1"/>
+          </p:cNvSpPr>
+          <p:nvPr>
+            <p:ph type="sldNum" sz="quarter" idx="12"/>
+          </p:nvPr>
+        </p:nvSpPr>
+        <p:spPr/>
+        <p:txBody>
+          <a:bodyPr/>
+          <a:lstStyle/>
+          <a:p>
+            <a:fld id="{AD78F8EF-AD73-49BA-8349-CA3A518C48B4}" type="slidenum">
+              <a:rPr lang="pt-PT" smtClean="0"/>
+              <a:pPr/>
+              <a:t>13</a:t>
+            </a:fld>
+            <a:endParaRPr lang="pt-PT" dirty="0"/>
+          </a:p>
+        </p:txBody>
+      </p:sp>
+      <p:sp>
+        <p:nvSpPr>
+          <p:cNvPr id="4" name="Espaço Reservado para Texto 3">
+            <a:extLst>
+              <a:ext uri="{FF2B5EF4-FFF2-40B4-BE49-F238E27FC236}">
+                <a16:creationId xmlns:a16="http://schemas.microsoft.com/office/drawing/2014/main" id="{9876B6E0-9526-82A9-77B8-5580055F9331}"/>
+              </a:ext>
+            </a:extLst>
+          </p:cNvPr>
+          <p:cNvSpPr>
+            <a:spLocks noGrp="1"/>
+          </p:cNvSpPr>
+          <p:nvPr>
+            <p:ph type="body" sz="quarter" idx="14"/>
+          </p:nvPr>
+        </p:nvSpPr>
+        <p:spPr>
+          <a:xfrm>
+            <a:off x="233421" y="16932"/>
+            <a:ext cx="6119754" cy="615366"/>
+          </a:xfrm>
+        </p:spPr>
+        <p:txBody>
+          <a:bodyPr anchor="ctr"/>
+          <a:lstStyle/>
+          <a:p>
+            <a:r>
+              <a:rPr lang="pt-BR" sz="2400" dirty="0"/>
+              <a:t>Shape e </a:t>
+            </a:r>
+            <a:r>
+              <a:rPr lang="pt-BR" sz="2400" dirty="0" err="1"/>
+              <a:t>GeoParquet</a:t>
+            </a:r>
+            <a:endParaRPr lang="pt-BR" sz="2400" dirty="0"/>
+          </a:p>
+        </p:txBody>
+      </p:sp>
+      <p:sp>
+        <p:nvSpPr>
+          <p:cNvPr id="5" name="CaixaDeTexto 4">
+            <a:extLst>
+              <a:ext uri="{FF2B5EF4-FFF2-40B4-BE49-F238E27FC236}">
+                <a16:creationId xmlns:a16="http://schemas.microsoft.com/office/drawing/2014/main" id="{EA1DE4A5-B8B1-BDB0-766C-1C47201C3E5B}"/>
+              </a:ext>
+            </a:extLst>
+          </p:cNvPr>
+          <p:cNvSpPr txBox="1"/>
+          <p:nvPr/>
+        </p:nvSpPr>
+        <p:spPr>
+          <a:xfrm>
+            <a:off x="233421" y="2268663"/>
+            <a:ext cx="5947269" cy="2308324"/>
+          </a:xfrm>
+          <a:prstGeom prst="rect">
+            <a:avLst/>
+          </a:prstGeom>
+          <a:noFill/>
+        </p:spPr>
+        <p:txBody>
+          <a:bodyPr wrap="none" rtlCol="0">
+            <a:spAutoFit/>
+          </a:bodyPr>
+          <a:lstStyle/>
+          <a:p>
+            <a:r>
+              <a:rPr lang="pt-BR" dirty="0"/>
+              <a:t>Arquivo binário</a:t>
+            </a:r>
+          </a:p>
+          <a:p>
+            <a:pPr marL="285750" indent="-285750">
+              <a:buFont typeface="Arial" panose="020B0604020202020204" pitchFamily="34" charset="0"/>
+              <a:buChar char="•"/>
+            </a:pPr>
+            <a:r>
+              <a:rPr lang="pt-BR" dirty="0"/>
+              <a:t>Arquivos voltados a representação de dados geográficos;</a:t>
+            </a:r>
+          </a:p>
+          <a:p>
+            <a:pPr marL="285750" indent="-285750">
+              <a:buFont typeface="Arial" panose="020B0604020202020204" pitchFamily="34" charset="0"/>
+              <a:buChar char="•"/>
+            </a:pPr>
+            <a:r>
+              <a:rPr lang="pt-BR" dirty="0"/>
+              <a:t>O IBGE disponibiliza diversas informações no formato SHP;</a:t>
+            </a:r>
+          </a:p>
+          <a:p>
+            <a:pPr marL="285750" indent="-285750">
+              <a:buFont typeface="Arial" panose="020B0604020202020204" pitchFamily="34" charset="0"/>
+              <a:buChar char="•"/>
+            </a:pPr>
+            <a:r>
+              <a:rPr lang="pt-BR" dirty="0"/>
+              <a:t>Arquivos </a:t>
+            </a:r>
+            <a:r>
+              <a:rPr lang="pt-BR" dirty="0" err="1"/>
+              <a:t>GeoParquet</a:t>
+            </a:r>
+            <a:r>
+              <a:rPr lang="pt-BR" dirty="0"/>
+              <a:t> podem ser utilizados em ambientes</a:t>
+            </a:r>
+            <a:br>
+              <a:rPr lang="pt-BR" dirty="0"/>
+            </a:br>
+            <a:r>
+              <a:rPr lang="pt-BR" dirty="0"/>
+              <a:t>de Big Data, que já possuam componentes Spark ou </a:t>
+            </a:r>
+            <a:r>
+              <a:rPr lang="pt-BR" dirty="0" err="1"/>
+              <a:t>Flink</a:t>
+            </a:r>
+            <a:r>
+              <a:rPr lang="pt-BR" dirty="0"/>
+              <a:t>;</a:t>
+            </a:r>
+          </a:p>
+          <a:p>
+            <a:pPr marL="285750" indent="-285750">
+              <a:buFont typeface="Arial" panose="020B0604020202020204" pitchFamily="34" charset="0"/>
+              <a:buChar char="•"/>
+            </a:pPr>
+            <a:r>
+              <a:rPr lang="pt-BR" dirty="0"/>
+              <a:t>Arquivos Shape são excelentes para representar polígonos.</a:t>
+            </a:r>
+          </a:p>
+          <a:p>
+            <a:pPr marL="285750" indent="-285750">
+              <a:buFont typeface="Arial" panose="020B0604020202020204" pitchFamily="34" charset="0"/>
+              <a:buChar char="•"/>
+            </a:pPr>
+            <a:endParaRPr lang="pt-BR" dirty="0"/>
+          </a:p>
+          <a:p>
+            <a:pPr marL="285750" indent="-285750">
+              <a:buFont typeface="Arial" panose="020B0604020202020204" pitchFamily="34" charset="0"/>
+              <a:buChar char="•"/>
+            </a:pPr>
+            <a:endParaRPr lang="pt-BR" dirty="0"/>
+          </a:p>
+        </p:txBody>
+      </p:sp>
+      <p:sp>
+        <p:nvSpPr>
+          <p:cNvPr id="6" name="CaixaDeTexto 5">
+            <a:extLst>
+              <a:ext uri="{FF2B5EF4-FFF2-40B4-BE49-F238E27FC236}">
+                <a16:creationId xmlns:a16="http://schemas.microsoft.com/office/drawing/2014/main" id="{D1200016-ACAB-58BD-702A-337B64F32943}"/>
+              </a:ext>
+            </a:extLst>
+          </p:cNvPr>
+          <p:cNvSpPr txBox="1"/>
+          <p:nvPr/>
+        </p:nvSpPr>
+        <p:spPr>
+          <a:xfrm>
+            <a:off x="233421" y="6028687"/>
+            <a:ext cx="3253391" cy="369332"/>
+          </a:xfrm>
+          <a:prstGeom prst="rect">
+            <a:avLst/>
+          </a:prstGeom>
+          <a:noFill/>
+        </p:spPr>
+        <p:txBody>
+          <a:bodyPr wrap="none" rtlCol="0">
+            <a:spAutoFit/>
+          </a:bodyPr>
+          <a:lstStyle/>
+          <a:p>
+            <a:r>
+              <a:rPr lang="pt-BR" dirty="0">
+                <a:hlinkClick r:id="rId2"/>
+              </a:rPr>
+              <a:t>geoparquet.org/releases/v1.0.0/</a:t>
+            </a:r>
+            <a:endParaRPr lang="pt-BR" dirty="0"/>
+          </a:p>
+        </p:txBody>
+      </p:sp>
+      <p:sp>
+        <p:nvSpPr>
+          <p:cNvPr id="7" name="CaixaDeTexto 6">
+            <a:extLst>
+              <a:ext uri="{FF2B5EF4-FFF2-40B4-BE49-F238E27FC236}">
+                <a16:creationId xmlns:a16="http://schemas.microsoft.com/office/drawing/2014/main" id="{CE0D4963-C400-5D22-2628-627A14B7C93F}"/>
+              </a:ext>
+            </a:extLst>
+          </p:cNvPr>
+          <p:cNvSpPr txBox="1"/>
+          <p:nvPr/>
+        </p:nvSpPr>
+        <p:spPr>
+          <a:xfrm>
+            <a:off x="233421" y="5659355"/>
+            <a:ext cx="3540841" cy="369332"/>
+          </a:xfrm>
+          <a:prstGeom prst="rect">
+            <a:avLst/>
+          </a:prstGeom>
+          <a:noFill/>
+        </p:spPr>
+        <p:txBody>
+          <a:bodyPr wrap="none" rtlCol="0">
+            <a:spAutoFit/>
+          </a:bodyPr>
+          <a:lstStyle/>
+          <a:p>
+            <a:r>
+              <a:rPr lang="pt-BR" dirty="0">
+                <a:hlinkClick r:id="rId3"/>
+              </a:rPr>
+              <a:t>ESRI </a:t>
+            </a:r>
+            <a:r>
+              <a:rPr lang="pt-BR" dirty="0" err="1">
+                <a:hlinkClick r:id="rId3"/>
+              </a:rPr>
+              <a:t>Shapefile</a:t>
+            </a:r>
+            <a:r>
+              <a:rPr lang="pt-BR" dirty="0">
+                <a:hlinkClick r:id="rId3"/>
+              </a:rPr>
+              <a:t> </a:t>
+            </a:r>
+            <a:r>
+              <a:rPr lang="pt-BR" dirty="0" err="1">
+                <a:hlinkClick r:id="rId3"/>
+              </a:rPr>
+              <a:t>Technical</a:t>
+            </a:r>
+            <a:r>
+              <a:rPr lang="pt-BR" dirty="0">
+                <a:hlinkClick r:id="rId3"/>
+              </a:rPr>
+              <a:t> </a:t>
+            </a:r>
+            <a:r>
+              <a:rPr lang="pt-BR" dirty="0" err="1">
+                <a:hlinkClick r:id="rId3"/>
+              </a:rPr>
+              <a:t>Description</a:t>
+            </a:r>
+            <a:endParaRPr lang="pt-BR" dirty="0"/>
+          </a:p>
+        </p:txBody>
+      </p:sp>
+    </p:spTree>
+    <p:extLst>
+      <p:ext uri="{BB962C8B-B14F-4D97-AF65-F5344CB8AC3E}">
+        <p14:creationId xmlns:p14="http://schemas.microsoft.com/office/powerpoint/2010/main" val="585118700"/>
+      </p:ext>
+    </p:extLst>
+  </p:cSld>
+  <p:clrMapOvr>
+    <a:masterClrMapping/>
+  </p:clrMapOvr>
+</p:sld>
+</file>
+
+<file path=ppt/slides/slide14.xml><?xml version="1.0" encoding="utf-8"?>
 <p:sld xmlns:a="http://schemas.openxmlformats.org/drawingml/2006/main" xmlns:r="http://schemas.openxmlformats.org/officeDocument/2006/relationships" xmlns:p="http://schemas.openxmlformats.org/presentationml/2006/main">
   <p:cSld>
     <p:spTree>
@@ -13830,15 +14147,6 @@
 </file>
 
 <file path=customXml/item1.xml><?xml version="1.0" encoding="utf-8"?>
-<?mso-contentType ?>
-<FormTemplates xmlns="http://schemas.microsoft.com/sharepoint/v3/contenttype/forms">
-  <Display>DocumentLibraryForm</Display>
-  <Edit>DocumentLibraryForm</Edit>
-  <New>DocumentLibraryForm</New>
-</FormTemplates>
-</file>
-
-<file path=customXml/item2.xml><?xml version="1.0" encoding="utf-8"?>
 <p:properties xmlns:p="http://schemas.microsoft.com/office/2006/metadata/properties" xmlns:xsi="http://www.w3.org/2001/XMLSchema-instance" xmlns:pc="http://schemas.microsoft.com/office/infopath/2007/PartnerControls">
   <documentManagement>
     <lcf76f155ced4ddcb4097134ff3c332f xmlns="aaa66e33-fa01-4ae6-8609-ebb9fdb5c96b">
@@ -13847,6 +14155,15 @@
     <TaxCatchAll xmlns="3ddadd9a-1469-4088-bffb-741804bca10e" xsi:nil="true"/>
   </documentManagement>
 </p:properties>
+</file>
+
+<file path=customXml/item2.xml><?xml version="1.0" encoding="utf-8"?>
+<?mso-contentType ?>
+<FormTemplates xmlns="http://schemas.microsoft.com/sharepoint/v3/contenttype/forms">
+  <Display>DocumentLibraryForm</Display>
+  <Edit>DocumentLibraryForm</Edit>
+  <New>DocumentLibraryForm</New>
+</FormTemplates>
 </file>
 
 <file path=customXml/item3.xml><?xml version="1.0" encoding="utf-8"?>
@@ -14073,20 +14390,20 @@
 </file>
 
 <file path=customXml/itemProps1.xml><?xml version="1.0" encoding="utf-8"?>
-<ds:datastoreItem xmlns:ds="http://schemas.openxmlformats.org/officeDocument/2006/customXml" ds:itemID="{59B446A2-A829-4306-AC94-DAF82F2AD6D9}">
-  <ds:schemaRefs>
-    <ds:schemaRef ds:uri="http://schemas.microsoft.com/sharepoint/v3/contenttype/forms"/>
-  </ds:schemaRefs>
-</ds:datastoreItem>
-</file>
-
-<file path=customXml/itemProps2.xml><?xml version="1.0" encoding="utf-8"?>
 <ds:datastoreItem xmlns:ds="http://schemas.openxmlformats.org/officeDocument/2006/customXml" ds:itemID="{4D59D27F-DE0C-4EE5-BEE4-FDD10F708E02}">
   <ds:schemaRefs>
     <ds:schemaRef ds:uri="http://schemas.microsoft.com/office/2006/metadata/properties"/>
     <ds:schemaRef ds:uri="http://schemas.microsoft.com/office/infopath/2007/PartnerControls"/>
     <ds:schemaRef ds:uri="aaa66e33-fa01-4ae6-8609-ebb9fdb5c96b"/>
     <ds:schemaRef ds:uri="3ddadd9a-1469-4088-bffb-741804bca10e"/>
+  </ds:schemaRefs>
+</ds:datastoreItem>
+</file>
+
+<file path=customXml/itemProps2.xml><?xml version="1.0" encoding="utf-8"?>
+<ds:datastoreItem xmlns:ds="http://schemas.openxmlformats.org/officeDocument/2006/customXml" ds:itemID="{59B446A2-A829-4306-AC94-DAF82F2AD6D9}">
+  <ds:schemaRefs>
+    <ds:schemaRef ds:uri="http://schemas.microsoft.com/sharepoint/v3/contenttype/forms"/>
   </ds:schemaRefs>
 </ds:datastoreItem>
 </file>

</xml_diff>